<commit_message>
feat: complete Theme 05 realtime agent submission
</commit_message>
<xml_diff>
--- a/docs/hackathon/submission/CollegeName_TeamName_Submission_ppt/CollegeName_TeamName_Submission_ppt.pptx
+++ b/docs/hackathon/submission/CollegeName_TeamName_Submission_ppt/CollegeName_TeamName_Submission_ppt.pptx
@@ -1276,7 +1276,7 @@
   <p:cSld>
     <p:spTree>
       <p:nvGrpSpPr>
-        <p:cNvPr id="23" name="" descr="&lt;Slide style={{&#10;    width: 1280,&#10;    height: 720,&#10;    padding: '0 72px',&#10;    background: '#FFFFFF',&#10;}}&gt;&#10;    &lt;Box style={{ width: '100%', height: 720, flexDirection: 'column' }}&gt;&#10;        &lt;Box style={{&#10;            height: 120,&#10;            paddingTop: 20,&#10;            paddingBottom: 16,&#10;            flexDirection: 'column',&#10;            justifyContent: 'flex-end',&#10;        }}&gt;&#10;            &lt;Box style={{ width: 56, height: 6, background: '#97C459', marginBottom: 14 }} /&gt;&#10;            &lt;Text style={{ fontFamily: 'Inter', fontSize: 34, fontWeight: 'bold', color: '#0B1F1A' }}&gt;&#10;                Tools and tech stack&#10;            &lt;/Text&gt;&#10;        &lt;/Box&gt;&#10;&#10;        &lt;Box style={{ height: 540, flexDirection: 'row', gap: 34 }}&gt;&#10;            &lt;Box style={{&#10;                width: 300,&#10;                background: 'linear-gradient(160deg, #04342C 0%, #0F6E56 100%)',&#10;                padding: '28px 24px',&#10;                flexDirection: 'column',&#10;            }}&gt;&#10;                &lt;Text style={{ fontFamily: 'JetBrains Mono', fontSize: 13, color: '#97C459', letterSpacing: 1.6 }}&gt;&#10;                    A DYNAMIC MANIFEST&#10;                &lt;/Text&gt;&#10;                &lt;Text style={{ fontFamily: 'Inter', fontSize: 22, fontWeight: 'bold', color: '#FFFFFF', lineHeight: 1.45, marginTop: 18 }}&gt;&#10;                    Ten tools, each declaring what it is allowed to do&#10;                &lt;/Text&gt;&#10;                &lt;Text style={{ fontFamily: 'Inter', fontSize: 16, lineHeight: 1.55, color: 'rgba(225,245,238,0.88)', marginTop: 16 }}&gt;&#10;                    Effect, blocking behaviour, scope and idempotency are declared once and enforced at dispatch. Nine tools can&#10;                    only read. Exactly one can write.&#10;                &lt;/Text&gt;&#10;                &lt;Box style={{ marginTop: 'auto', paddingTop: 18 }}&gt;&#10;                    &lt;Box style={{ height: 1, background: 'rgba(225,245,238,0.28)', marginBottom: 14 }} /&gt;&#10;                    &lt;Text style={{ fontFamily: 'JetBrains Mono', fontSize: 13, color: '#97C459' }}&gt;&#10;                        DRIFT GUARD&#10;                    &lt;/Text&gt;&#10;                    &lt;Text style={{ fontFamily: 'Inter', fontSize: 15, lineHeight: 1.5, color: 'rgba(225,245,238,0.82)', marginTop: 6 }}&gt;&#10;                        A test fails if any declared tool is missing from the system prompt, so the manifest and the instructions&#10;                        cannot drift apart.&#10;                    &lt;/Text&gt;&#10;                &lt;/Box&gt;&#10;            &lt;/Box&gt;&#10;&#10;            &lt;Box style={{ width: 802, flexDirection: 'column', gap: 24 }}&gt;&#10;                &lt;Box style={{&#10;                    height: 300,&#10;                    border: '1px solid #E1F5EE',&#10;                    padding: '20px 24px',&#10;                    flexDirection: 'column',&#10;                }}&gt;&#10;                    &lt;Text style={{ fontFamily: 'JetBrains Mono', fontSize: 13, color: '#0F6E56', letterSpacing: 1.5 }}&gt;&#10;                        READ-ONLY · 9 TOOLS&#10;                    &lt;/Text&gt;&#10;                    &lt;Box style={{ flexDirection: 'row', flexWrap: 'wrap', gap: 10, marginTop: 14 }}&gt;&#10;                        &lt;Box style={{ padding: '7px 14px', background: '#E1F5EE', borderRadius: 4 }}&gt;&#10;                            &lt;Text style={{ fontFamily: 'JetBrains Mono', fontSize: 14, color: '#04342C' }}&gt;search_candidates&lt;/Text&gt;&#10;                        &lt;/Box&gt;&#10;                        &lt;Box style={{ padding: '7px 14px', background: '#E1F5EE', borderRadius: 4 }}&gt;&#10;                            &lt;Text style={{ fontFamily: 'JetBrains Mono', fontSize: 14, color: '#04342C' }}&gt;inspect_candidate&lt;/Text&gt;&#10;                        &lt;/Box&gt;&#10;                        &lt;Box style={{ padding: '7px 14px', background: '#E1F5EE', borderRadius: 4 }}&gt;&#10;                            &lt;Text style={{ fontFamily: 'JetBrains Mono', fontSize: 14, color: '#04342C' }}&gt;compare_candidates&lt;/Text&gt;&#10;                        &lt;/Box&gt;&#10;                        &lt;Box style={{ padding: '7px 14px', background: '#E1F5EE', borderRadius: 4 }}&gt;&#10;                            &lt;Text style={{ fontFamily: 'JetBrains Mono', fontSize: 14, color: '#04342C' }}&gt;list_skills&lt;/Text&gt;&#10;                        &lt;/Box&gt;&#10;                        &lt;Box style={{ padding: '7px 14px', background: '#E1F5EE', borderRadius: 4 }}&gt;&#10;                            &lt;Text style={{ fontFamily: 'JetBrains Mono', fontSize: 14, color: '#04342C' }}&gt;use_role_image&lt;/Text&gt;&#10;                        &lt;/Box&gt;&#10;                        &lt;Box style={{ padding: '7px 14px', background: '#E1F5EE', borderRadius: 4 }}&gt;&#10;                            &lt;Text style={{ fontFamily: 'JetBrains Mono', fontSize: 14, color: '#04342C' }}&gt;format_current_answer&lt;/Text&gt;&#10;                        &lt;/Box&gt;&#10;                        &lt;Box style={{ padding: '7px 14px', background: '#E1F5EE', borderRadius: 4 }}&gt;&#10;                            &lt;Text style={{ fontFamily: 'JetBrains Mono', fontSize: 14, color: '#04342C' }}&gt;interrupt_search&lt;/Text&gt;&#10;                        &lt;/Box&gt;&#10;                        &lt;Box style={{ padding: '7px 14px', background: '#E1F5EE', borderRadius: 4 }}&gt;&#10;                            &lt;Text style={{ fontFamily: 'JetBrains Mono', fontSize: 14, color: '#04342C' }}&gt;cancel_current_action&lt;/Text&gt;&#10;                        &lt;/Box&gt;&#10;                        &lt;Box style={{ padding: '7px 14px', background: '#E1F5EE', borderRadius: 4 }}&gt;&#10;                            &lt;Text style={{ fontFamily: 'JetBrains Mono', fontSize: 14, color: '#04342C' }}&gt;request_clarification&lt;/Text&gt;&#10;                        &lt;/Box&gt;&#10;                    &lt;/Box&gt;&#10;&#10;                    &lt;Box style={{ height: 1, background: '#E1F5EE', marginTop: 'auto', marginBottom: 18 }} /&gt;&#10;&#10;                    &lt;Text style={{ fontFamily: 'JetBrains Mono', fontSize: 13, color: '#0F6E56', letterSpacing: 1.5 }}&gt;&#10;                        STATE-MODIFYING · 1 TOOL&#10;                    &lt;/Text&gt;&#10;                    &lt;Box style={{ flexDirection: 'row', alignItems: 'center', gap: 16, marginTop: 14 }}&gt;&#10;                        &lt;Box style={{ padding: '9px 16px', background: '#04342C', borderRadius: 4 }}&gt;&#10;                            &lt;Text style={{ fontFamily: 'JetBrains Mono', fontSize: 15, color: '#97C459', fontWeight: 'bold' }}&gt;&#10;                                add_to_shortlist&#10;                            &lt;/Text&gt;&#10;                        &lt;/Box&gt;&#10;                        &lt;Text style={{ fontFamily: 'Inter', fontSize: 15.5, color: '#6B7280', flex: 1 }}&gt;&#10;                            Idempotency key · scope supersession · recorded in the effect log&#10;                        &lt;/Text&gt;&#10;                    &lt;/Box&gt;&#10;                &lt;/Box&gt;&#10;&#10;                &lt;Box style={{ height: 216, flexDirection: 'column' }}&gt;&#10;                    &lt;Box style={{ flexDirection: 'row', paddingBottom: 8, borderBottom: '2px solid #04342C' }}&gt;&#10;                        &lt;Text style={{ fontFamily: 'JetBrains Mono', fontSize: 12, color: '#6B7280', letterSpacing: 1.5, width: 150 }}&gt;&#10;                            LAYER&#10;                        &lt;/Text&gt;&#10;                        &lt;Text style={{ fontFamily: 'JetBrains Mono', fontSize: 12, color: '#6B7280', letterSpacing: 1.5, flex: 1, paddingLeft: 16 }}&gt;&#10;                            WHAT WE USE&#10;                        &lt;/Text&gt;&#10;                    &lt;/Box&gt;&#10;                    &lt;Box style={{ flexDirection: 'row', alignItems: 'center', height: 38, borderBottom: '1px solid #E1F5EE' }}&gt;&#10;                        &lt;Text style={{ fontFamily: 'Inter', fontSize: 15, fontWeight: 600, color: '#0B1F1A', width: 150 }}&gt;Transport&lt;/Text&gt;&#10;                        &lt;Text style={{ fontFamily: 'Inter', fontSize: 15, color: '#6B7280', flex: 1, paddingLeft: 16 }}&gt;&#10;                            Gemini Live (full duplex) · FastAPI · Uvicorn&#10;                        &lt;/Text&gt;&#10;                    &lt;/Box&gt;&#10;                    &lt;Box style={{ flexDirection: 'row', alignItems: 'center', height: 38, borderBottom: '1px solid #E1F5EE' }}&gt;&#10;                        &lt;Text style={{ fontFamily: 'Inter', fontSize: 15, fontWeight: 600, color: '#0B1F1A', width: 150 }}&gt;Data&lt;/Text&gt;&#10;                        &lt;Text style={{ fontFamily: 'Inter', fontSize: 15, color: '#6B7280', flex: 1, paddingLeft: 16 }}&gt;&#10;                            PostgreSQL 17 + pgvector · PgBouncer · Redis 7&#10;                        &lt;/Text&gt;&#10;                    &lt;/Box&gt;&#10;                    &lt;Box style={{ flexDirection: 'row', alignItems: 'center', height: 38, borderBottom: '1px solid #E1F5EE' }}&gt;&#10;                        &lt;Text style={{ fontFamily: 'Inter', fontSize: 15, fontWeight: 600, color: '#0B1F1A', width: 150 }}&gt;Retrieval&lt;/Text&gt;&#10;                        &lt;Text style={{ fontFamily: 'Inter', fontSize: 15, color: '#6B7280', flex: 1, paddingLeft: 16 }}&gt;&#10;                            vector + BM25 + SQL + skills · RRF fusion · rerank&#10;                        &lt;/Text&gt;&#10;                    &lt;/Box&gt;&#10;                    &lt;Box style={{ flexDirection: 'row', alignItems: 'center', height: 38, borderBottom: '1px solid #E1F5EE' }}&gt;&#10;                        &lt;Text style={{ fontFamily: 'Inter', fontSize: 15, fontWeight: 600, color: '#0B1F1A', width: 150 }}&gt;Runtime&lt;/Text&gt;&#10;                        &lt;Text style={{ fontFamily: 'Inter', fontSize: 15, color: '#6B7280', flex: 1, paddingLeft: 16 }}&gt;&#10;                            Python 3.13 · pydantic v2 · Docker Compose&#10;                        &lt;/Text&gt;&#10;                    &lt;/Box&gt;&#10;                    &lt;Box style={{ flexDirection: 'row', alignItems: 'center', height: 38 }}&gt;&#10;                        &lt;Text style={{ fontFamily: 'Inter', fontSize: 15, fontWeight: 600, color: '#0B1F1A', width: 150 }}&gt;Verification&lt;/Text&gt;&#10;                        &lt;Text style={{ fontFamily: 'Inter', fontSize: 15, color: '#6B7280', flex: 1, paddingLeft: 16 }}&gt;&#10;                            pytest · pytest-asyncio · ruff · jsdom&#10;                        &lt;/Text&gt;&#10;                    &lt;/Box&gt;&#10;                &lt;/Box&gt;&#10;            &lt;/Box&gt;&#10;        &lt;/Box&gt;&#10;&#10;        &lt;Box style={{&#10;            height: 60,&#10;            paddingBottom: 20,&#10;            flexDirection: 'row',&#10;            alignItems: 'center',&#10;            justifyContent: 'space-between',&#10;        }}&gt;&#10;            &lt;Text style={{ fontFamily: 'Inter', fontSize: 14, color: '#6B7280' }}&gt;&#10;                Talent Atlas · Samsung PRISM Y2026 · Theme 05&#10;            &lt;/Text&gt;&#10;            &lt;Text style={{ fontFamily: 'JetBrains Mono', fontSize: 14, color: '#6B7280' }}&gt;&#10;                10 / 12&#10;            &lt;/Text&gt;&#10;        &lt;/Box&gt;&#10;    &lt;/Box&gt;&#10;&lt;/Slide&gt;&#10;"/>
+        <p:cNvPr id="23" name="" descr="&lt;Slide style={{&#10;    width: 1280,&#10;    height: 720,&#10;    padding: '0 72px',&#10;    background: '#FFFFFF',&#10;}}&gt;&#10;    &lt;Box style={{ width: '100%', height: 720, flexDirection: 'column' }}&gt;&#10;        &lt;Box style={{&#10;            height: 120,&#10;            paddingTop: 20,&#10;            paddingBottom: 16,&#10;            flexDirection: 'column',&#10;            justifyContent: 'flex-end',&#10;        }}&gt;&#10;            &lt;Box style={{ width: 56, height: 6, background: '#97C459', marginBottom: 14 }} /&gt;&#10;            &lt;Text style={{ fontFamily: 'Inter', fontSize: 34, fontWeight: 'bold', color: '#0B1F1A' }}&gt;&#10;                Tools and tech stack&#10;            &lt;/Text&gt;&#10;        &lt;/Box&gt;&#10;&#10;        &lt;Box style={{ height: 540, flexDirection: 'row', gap: 34 }}&gt;&#10;            &lt;Box style={{&#10;                width: 300,&#10;                background: 'linear-gradient(160deg, #04342C 0%, #0F6E56 100%)',&#10;                padding: '28px 24px',&#10;                flexDirection: 'column',&#10;            }}&gt;&#10;                &lt;Text style={{ fontFamily: 'JetBrains Mono', fontSize: 13, color: '#97C459', letterSpacing: 1.6 }}&gt;&#10;                    A DYNAMIC MANIFEST&#10;                &lt;/Text&gt;&#10;                &lt;Text style={{ fontFamily: 'Inter', fontSize: 22, fontWeight: 'bold', color: '#FFFFFF', lineHeight: 1.45, marginTop: 18 }}&gt;&#10;                    Ten tools, each declaring what it is allowed to do&#10;                &lt;/Text&gt;&#10;                &lt;Text style={{ fontFamily: 'Inter', fontSize: 16, lineHeight: 1.55, color: 'rgba(225,245,238,0.88)', marginTop: 16 }}&gt;&#10;                    Effect, blocking behaviour, scope and idempotency are declared once and enforced at dispatch. Nine tools can&#10;                    only read. Exactly one can write.&#10;                &lt;/Text&gt;&#10;                &lt;Box style={{ marginTop: 'auto', paddingTop: 18 }}&gt;&#10;                    &lt;Box style={{ height: 1, background: 'rgba(225,245,238,0.28)', marginBottom: 14 }} /&gt;&#10;                    &lt;Text style={{ fontFamily: 'JetBrains Mono', fontSize: 13, color: '#97C459' }}&gt;&#10;                        DRIFT GUARD&#10;                    &lt;/Text&gt;&#10;                    &lt;Text style={{ fontFamily: 'Inter', fontSize: 15, lineHeight: 1.5, color: 'rgba(225,245,238,0.82)', marginTop: 6 }}&gt;&#10;                        A test fails if any declared tool is missing from the system prompt, so the manifest and the instructions&#10;                        cannot drift apart.&#10;                    &lt;/Text&gt;&#10;                &lt;/Box&gt;&#10;            &lt;/Box&gt;&#10;&#10;            &lt;Box style={{ width: 802, flexDirection: 'column', gap: 24 }}&gt;&#10;                &lt;Box style={{&#10;                    height: 300,&#10;                    border: '1px solid #E1F5EE',&#10;                    padding: '20px 24px',&#10;                    flexDirection: 'column',&#10;                }}&gt;&#10;                    &lt;Text style={{ fontFamily: 'JetBrains Mono', fontSize: 13, color: '#0F6E56', letterSpacing: 1.5 }}&gt;&#10;                        READ-ONLY · 9 TOOLS&#10;                    &lt;/Text&gt;&#10;                    &lt;Box style={{ flexDirection: 'row', flexWrap: 'wrap', gap: 10, marginTop: 14 }}&gt;&#10;                        &lt;Box style={{ padding: '7px 14px', background: '#E1F5EE', borderRadius: 4 }}&gt;&#10;                            &lt;Text style={{ fontFamily: 'JetBrains Mono', fontSize: 14, color: '#04342C' }}&gt;search_candidates&lt;/Text&gt;&#10;                        &lt;/Box&gt;&#10;                        &lt;Box style={{ padding: '7px 14px', background: '#E1F5EE', borderRadius: 4 }}&gt;&#10;                            &lt;Text style={{ fontFamily: 'JetBrains Mono', fontSize: 14, color: '#04342C' }}&gt;inspect_candidate&lt;/Text&gt;&#10;                        &lt;/Box&gt;&#10;                        &lt;Box style={{ padding: '7px 14px', background: '#E1F5EE', borderRadius: 4 }}&gt;&#10;                            &lt;Text style={{ fontFamily: 'JetBrains Mono', fontSize: 14, color: '#04342C' }}&gt;compare_candidates&lt;/Text&gt;&#10;                        &lt;/Box&gt;&#10;                        &lt;Box style={{ padding: '7px 14px', background: '#E1F5EE', borderRadius: 4 }}&gt;&#10;                            &lt;Text style={{ fontFamily: 'JetBrains Mono', fontSize: 14, color: '#04342C' }}&gt;list_skills&lt;/Text&gt;&#10;                        &lt;/Box&gt;&#10;                        &lt;Box style={{ padding: '7px 14px', background: '#E1F5EE', borderRadius: 4 }}&gt;&#10;                            &lt;Text style={{ fontFamily: 'JetBrains Mono', fontSize: 14, color: '#04342C' }}&gt;use_role_image&lt;/Text&gt;&#10;                        &lt;/Box&gt;&#10;                        &lt;Box style={{ padding: '7px 14px', background: '#E1F5EE', borderRadius: 4 }}&gt;&#10;                            &lt;Text style={{ fontFamily: 'JetBrains Mono', fontSize: 14, color: '#04342C' }}&gt;format_current_answer&lt;/Text&gt;&#10;                        &lt;/Box&gt;&#10;                        &lt;Box style={{ padding: '7px 14px', background: '#E1F5EE', borderRadius: 4 }}&gt;&#10;                            &lt;Text style={{ fontFamily: 'JetBrains Mono', fontSize: 14, color: '#04342C' }}&gt;interrupt_search&lt;/Text&gt;&#10;                        &lt;/Box&gt;&#10;                        &lt;Box style={{ padding: '7px 14px', background: '#E1F5EE', borderRadius: 4 }}&gt;&#10;                            &lt;Text style={{ fontFamily: 'JetBrains Mono', fontSize: 14, color: '#04342C' }}&gt;cancel_current_action&lt;/Text&gt;&#10;                        &lt;/Box&gt;&#10;                        &lt;Box style={{ padding: '7px 14px', background: '#E1F5EE', borderRadius: 4 }}&gt;&#10;                            &lt;Text style={{ fontFamily: 'JetBrains Mono', fontSize: 14, color: '#04342C' }}&gt;request_clarification&lt;/Text&gt;&#10;                        &lt;/Box&gt;&#10;                    &lt;/Box&gt;&#10;&#10;                    &lt;Box style={{ height: 1, background: '#E1F5EE', marginTop: 'auto', marginBottom: 18 }} /&gt;&#10;&#10;                    &lt;Text style={{ fontFamily: 'JetBrains Mono', fontSize: 13, color: '#0F6E56', letterSpacing: 1.5 }}&gt;&#10;                        STATE-MODIFYING · 1 TOOL&#10;                    &lt;/Text&gt;&#10;                    &lt;Box style={{ flexDirection: 'row', alignItems: 'center', gap: 16, marginTop: 14 }}&gt;&#10;                        &lt;Box style={{ padding: '9px 16px', background: '#04342C', borderRadius: 4 }}&gt;&#10;                            &lt;Text style={{ fontFamily: 'JetBrains Mono', fontSize: 15, color: '#97C459', fontWeight: 'bold' }}&gt;&#10;                                add_to_shortlist&#10;                            &lt;/Text&gt;&#10;                        &lt;/Box&gt;&#10;                        &lt;Text style={{ fontFamily: 'Inter', fontSize: 15.5, color: '#6B7280', flex: 1 }}&gt;&#10;                            Idempotency key · scope supersession · recorded in the effect log&#10;                        &lt;/Text&gt;&#10;                    &lt;/Box&gt;&#10;                &lt;/Box&gt;&#10;&#10;                &lt;Box style={{ height: 216, flexDirection: 'column' }}&gt;&#10;                    &lt;Box style={{ flexDirection: 'row', paddingBottom: 8, borderBottom: '2px solid #04342C' }}&gt;&#10;                        &lt;Text style={{ fontFamily: 'JetBrains Mono', fontSize: 12, color: '#6B7280', letterSpacing: 1.5, width: 150 }}&gt;&#10;                            LAYER&#10;                        &lt;/Text&gt;&#10;                        &lt;Text style={{ fontFamily: 'JetBrains Mono', fontSize: 12, color: '#6B7280', letterSpacing: 1.5, flex: 1, paddingLeft: 16 }}&gt;&#10;                            WHAT WE USE&#10;                        &lt;/Text&gt;&#10;                    &lt;/Box&gt;&#10;                    &lt;Box style={{ flexDirection: 'row', alignItems: 'center', height: 38, borderBottom: '1px solid #E1F5EE' }}&gt;&#10;                        &lt;Text style={{ fontFamily: 'Inter', fontSize: 15, fontWeight: 600, color: '#0B1F1A', width: 150 }}&gt;Transport&lt;/Text&gt;&#10;                        &lt;Text style={{ fontFamily: 'Inter', fontSize: 15, color: '#6B7280', flex: 1, paddingLeft: 16 }}&gt;&#10;                            Gemini Live (full duplex) · FastAPI · Uvicorn&#10;                        &lt;/Text&gt;&#10;                    &lt;/Box&gt;&#10;                    &lt;Box style={{ flexDirection: 'row', alignItems: 'center', height: 38, borderBottom: '1px solid #E1F5EE' }}&gt;&#10;                        &lt;Text style={{ fontFamily: 'Inter', fontSize: 15, fontWeight: 600, color: '#0B1F1A', width: 150 }}&gt;Data&lt;/Text&gt;&#10;                        &lt;Text style={{ fontFamily: 'Inter', fontSize: 15, color: '#6B7280', flex: 1, paddingLeft: 16 }}&gt;&#10;                            PostgreSQL 17 + pgvector · PgBouncer · Redis 7&#10;                        &lt;/Text&gt;&#10;                    &lt;/Box&gt;&#10;                    &lt;Box style={{ flexDirection: 'row', alignItems: 'center', height: 38, borderBottom: '1px solid #E1F5EE' }}&gt;&#10;                        &lt;Text style={{ fontFamily: 'Inter', fontSize: 15, fontWeight: 600, color: '#0B1F1A', width: 150 }}&gt;Retrieval&lt;/Text&gt;&#10;                        &lt;Text style={{ fontFamily: 'Inter', fontSize: 15, color: '#6B7280', flex: 1, paddingLeft: 16 }}&gt;&#10;                            vector + BM25 + SQL + skills · RRF fusion · rerank&#10;                        &lt;/Text&gt;&#10;                    &lt;/Box&gt;&#10;                    &lt;Box style={{ flexDirection: 'row', alignItems: 'center', height: 38, borderBottom: '1px solid #E1F5EE' }}&gt;&#10;                        &lt;Text style={{ fontFamily: 'Inter', fontSize: 15, fontWeight: 600, color: '#0B1F1A', width: 150 }}&gt;Runtime&lt;/Text&gt;&#10;                        &lt;Text style={{ fontFamily: 'Inter', fontSize: 15, color: '#6B7280', flex: 1, paddingLeft: 16 }}&gt;&#10;                            Python 3.11 · pydantic v2 · Docker Compose&#10;                        &lt;/Text&gt;&#10;                    &lt;/Box&gt;&#10;                    &lt;Box style={{ flexDirection: 'row', alignItems: 'center', height: 38 }}&gt;&#10;                        &lt;Text style={{ fontFamily: 'Inter', fontSize: 15, fontWeight: 600, color: '#0B1F1A', width: 150 }}&gt;Verification&lt;/Text&gt;&#10;                        &lt;Text style={{ fontFamily: 'Inter', fontSize: 15, color: '#6B7280', flex: 1, paddingLeft: 16 }}&gt;&#10;                            pytest · pytest-asyncio · ruff · jsdom&#10;                        &lt;/Text&gt;&#10;                    &lt;/Box&gt;&#10;                &lt;/Box&gt;&#10;            &lt;/Box&gt;&#10;        &lt;/Box&gt;&#10;&#10;        &lt;Box style={{&#10;            height: 60,&#10;            paddingBottom: 20,&#10;            flexDirection: 'row',&#10;            alignItems: 'center',&#10;            justifyContent: 'space-between',&#10;        }}&gt;&#10;            &lt;Text style={{ fontFamily: 'Inter', fontSize: 14, color: '#6B7280' }}&gt;&#10;                Talent Atlas · Samsung PRISM Y2026 · Theme 05&#10;            &lt;/Text&gt;&#10;            &lt;Text style={{ fontFamily: 'JetBrains Mono', fontSize: 14, color: '#6B7280' }}&gt;&#10;                10 / 12&#10;            &lt;/Text&gt;&#10;        &lt;/Box&gt;&#10;    &lt;/Box&gt;&#10;&lt;/Slide&gt;&#10;"/>
         <p:cNvGrpSpPr/>
         <p:nvPr/>
       </p:nvGrpSpPr>
@@ -2923,7 +2923,7 @@
                 <a:latin typeface="Inter"/>
                 <a:ea typeface="Inter"/>
               </a:rPr>
-              <a:t>Python 3.13 · pydantic v2 · Docker Compose</a:t>
+              <a:t>Python 3.11 · pydantic v2 · Docker Compose</a:t>
             </a:r>
             <a:endParaRPr/>
           </a:p>
@@ -6106,7 +6106,7 @@
                 <a:latin typeface="JetBrains Mono"/>
                 <a:ea typeface="JetBrains Mono"/>
               </a:rPr>
-              <a:t>654</a:t>
+              <a:t>670</a:t>
             </a:r>
             <a:endParaRPr/>
           </a:p>

</xml_diff>